<commit_message>
feat(cheil): one name per common blank across the six templates
Plan item 1. The same information went by a different blank in each
template ([광고주] / [광고주명], [예산 합계] / [RFP에 적힌 예산 규모],
[제출일] / [보고일] / [날짜]). packages/ui/src/cheil-fields.json now
names the ten common blanks once (campaign, client, brand, period,
budget, target, KPI, team, author, date) with their aliases.

- make_templates.py builds the templates from the dictionary and reopens
  each file: an alias, or a non-common blank appearing twice, fails it
- cheil-fields.ts: lookup by name or alias, the hint the one-call fill
  now sends with a common blank, and a campaign card's values for them
- the six templates regenerated; brief, meeting notes, pitch analysis
  and media plan gained the period/budget/KPI/client rows the card fills
- tests/cheil-fields.test.ts opens the shipped templates and checks them

Co-Authored-By: Claude Opus 5.5 <noreply@anthropic.com>
</commit_message>
<xml_diff>
--- a/apps/shell/resources/builtin-skills/cheil-monthly-report/assets/월간 성과 보고서.pptx
+++ b/apps/shell/resources/builtin-skills/cheil-monthly-report/assets/월간 성과 보고서.pptx
@@ -3160,7 +3160,7 @@
                 </a:solidFill>
                 <a:latin typeface="맑은 고딕"/>
               </a:rPr>
-              <a:t>[광고주명] [월] 캠페인 성과 보고</a:t>
+              <a:t>[광고주] [캠페인명] [월] 성과 보고</a:t>
             </a:r>
           </a:p>
         </p:txBody>
@@ -3188,7 +3188,7 @@
                 </a:solidFill>
                 <a:latin typeface="맑은 고딕"/>
               </a:rPr>
-              <a:t>[보고일]  ·  [팀명]</a:t>
+              <a:t>[작성일]  ·  [팀명]</a:t>
             </a:r>
           </a:p>
         </p:txBody>

</xml_diff>